<commit_message>
Integrate improved PPT generation logic and fix dependencies
</commit_message>
<xml_diff>
--- a/backend/storage/presentations/test_presentation.pptx
+++ b/backend/storage/presentations/test_presentation.pptx
@@ -10,7 +10,7 @@
     <p:sldId id="258" r:id="rId9"/>
     <p:sldId id="259" r:id="rId10"/>
   </p:sldIdLst>
-  <p:sldSz cx="12188952" cy="6858000" type="screen4x3"/>
+  <p:sldSz cx="9144000" cy="6858000" type="screen4x3"/>
   <p:notesSz cx="6858000" cy="9144000"/>
   <p:defaultTextStyle>
     <a:defPPr>
@@ -3093,33 +3093,20 @@
       <p:grpSpPr/>
       <p:sp>
         <p:nvSpPr>
-          <p:cNvPr id="2" name="TextBox 1"/>
-          <p:cNvSpPr txBox="1"/>
-          <p:nvPr/>
-        </p:nvSpPr>
-        <p:spPr>
-          <a:xfrm>
-            <a:off x="914400" y="1828800"/>
-            <a:ext cx="10360152" cy="1828800"/>
-          </a:xfrm>
-          <a:prstGeom prst="rect">
-            <a:avLst/>
-          </a:prstGeom>
-          <a:noFill/>
-        </p:spPr>
-        <p:txBody>
-          <a:bodyPr wrap="none">
-            <a:spAutoFit/>
-          </a:bodyPr>
-          <a:lstStyle/>
-          <a:p>
-            <a:pPr algn="ctr"/>
-            <a:r>
-              <a:rPr sz="4400" b="1">
-                <a:solidFill>
-                  <a:srgbClr val="1F497D"/>
-                </a:solidFill>
-              </a:rPr>
+          <p:cNvPr id="2" name="Title 1"/>
+          <p:cNvSpPr>
+            <a:spLocks noGrp="1"/>
+          </p:cNvSpPr>
+          <p:nvPr>
+            <p:ph type="ctrTitle"/>
+          </p:nvPr>
+        </p:nvSpPr>
+        <p:spPr/>
+        <p:txBody>
+          <a:bodyPr/>
+          <a:lstStyle/>
+          <a:p>
+            <a:r>
               <a:t>Introduction to Photosynthesis</a:t>
             </a:r>
           </a:p>
@@ -3127,78 +3114,22 @@
       </p:sp>
       <p:sp>
         <p:nvSpPr>
-          <p:cNvPr id="3" name="TextBox 2"/>
-          <p:cNvSpPr txBox="1"/>
-          <p:nvPr/>
-        </p:nvSpPr>
-        <p:spPr>
-          <a:xfrm>
-            <a:off x="914400" y="4114800"/>
-            <a:ext cx="10360152" cy="914400"/>
-          </a:xfrm>
-          <a:prstGeom prst="rect">
-            <a:avLst/>
-          </a:prstGeom>
-          <a:noFill/>
-        </p:spPr>
-        <p:txBody>
-          <a:bodyPr wrap="none">
-            <a:spAutoFit/>
-          </a:bodyPr>
-          <a:lstStyle/>
-          <a:p>
-            <a:pPr algn="ctr"/>
-            <a:r>
-              <a:rPr sz="2400">
-                <a:solidFill>
-                  <a:srgbClr val="4472C4"/>
-                </a:solidFill>
-              </a:rPr>
+          <p:cNvPr id="3" name="Subtitle 2"/>
+          <p:cNvSpPr>
+            <a:spLocks noGrp="1"/>
+          </p:cNvSpPr>
+          <p:nvPr>
+            <p:ph type="subTitle" idx="1"/>
+          </p:nvPr>
+        </p:nvSpPr>
+        <p:spPr/>
+        <p:txBody>
+          <a:bodyPr/>
+          <a:lstStyle/>
+          <a:p>
+            <a:r>
               <a:t>Educational Presentation</a:t>
             </a:r>
-          </a:p>
-        </p:txBody>
-      </p:sp>
-      <p:sp>
-        <p:nvSpPr>
-          <p:cNvPr id="4" name="Rectangle 3"/>
-          <p:cNvSpPr/>
-          <p:nvPr/>
-        </p:nvSpPr>
-        <p:spPr>
-          <a:xfrm>
-            <a:off x="914400" y="5943600"/>
-            <a:ext cx="10360152" cy="274320"/>
-          </a:xfrm>
-          <a:prstGeom prst="rect">
-            <a:avLst/>
-          </a:prstGeom>
-          <a:solidFill>
-            <a:srgbClr val="4472C4"/>
-          </a:solidFill>
-          <a:ln>
-            <a:noFill/>
-          </a:ln>
-        </p:spPr>
-        <p:style>
-          <a:lnRef idx="1">
-            <a:schemeClr val="accent1"/>
-          </a:lnRef>
-          <a:fillRef idx="3">
-            <a:schemeClr val="accent1"/>
-          </a:fillRef>
-          <a:effectRef idx="2">
-            <a:schemeClr val="accent1"/>
-          </a:effectRef>
-          <a:fontRef idx="minor">
-            <a:schemeClr val="lt1"/>
-          </a:fontRef>
-        </p:style>
-        <p:txBody>
-          <a:bodyPr rtlCol="0" anchor="ctr"/>
-          <a:lstStyle/>
-          <a:p>
-            <a:pPr algn="ctr"/>
           </a:p>
         </p:txBody>
       </p:sp>
@@ -3235,13 +3166,6 @@
           <a:bodyPr/>
           <a:lstStyle/>
           <a:p>
-            <a:pPr>
-              <a:defRPr sz="3200" b="1">
-                <a:solidFill>
-                  <a:srgbClr val="1F497D"/>
-                </a:solidFill>
-              </a:defRPr>
-            </a:pPr>
             <a:r>
               <a:t>What is Photosynthesis?</a:t>
             </a:r>
@@ -3263,81 +3187,21 @@
           <a:bodyPr/>
           <a:lstStyle/>
           <a:p>
-            <a:pPr>
-              <a:defRPr sz="2000">
-                <a:solidFill>
-                  <a:srgbClr val="444444"/>
-                </a:solidFill>
-              </a:defRPr>
-            </a:pPr>
+            <a:pPr/>
             <a:r>
               <a:t>Process by which plants convert light energy to chemical energy</a:t>
             </a:r>
           </a:p>
           <a:p>
-            <a:pPr>
-              <a:defRPr sz="2000">
-                <a:solidFill>
-                  <a:srgbClr val="444444"/>
-                </a:solidFill>
-              </a:defRPr>
-            </a:pPr>
+            <a:pPr/>
             <a:r>
               <a:t>Occurs in chloroplasts of plant cells</a:t>
             </a:r>
           </a:p>
           <a:p>
-            <a:pPr>
-              <a:defRPr sz="2000">
-                <a:solidFill>
-                  <a:srgbClr val="444444"/>
-                </a:solidFill>
-              </a:defRPr>
-            </a:pPr>
+            <a:pPr/>
             <a:r>
               <a:t>Essential for life on Earth</a:t>
-            </a:r>
-          </a:p>
-        </p:txBody>
-      </p:sp>
-      <p:sp>
-        <p:nvSpPr>
-          <p:cNvPr id="4" name="TextBox 3"/>
-          <p:cNvSpPr txBox="1"/>
-          <p:nvPr/>
-        </p:nvSpPr>
-        <p:spPr>
-          <a:xfrm>
-            <a:off x="7315200" y="5029200"/>
-            <a:ext cx="4114800" cy="1371600"/>
-          </a:xfrm>
-          <a:prstGeom prst="rect">
-            <a:avLst/>
-          </a:prstGeom>
-          <a:solidFill>
-            <a:srgbClr val="F0F0F0"/>
-          </a:solidFill>
-        </p:spPr>
-        <p:txBody>
-          <a:bodyPr wrap="none">
-            <a:spAutoFit/>
-          </a:bodyPr>
-          <a:lstStyle/>
-          <a:p>
-            <a:pPr>
-              <a:defRPr sz="1200" i="1">
-                <a:solidFill>
-                  <a:srgbClr val="808080"/>
-                </a:solidFill>
-              </a:defRPr>
-            </a:pPr>
-            <a:r>
-              <a:t>💡 Visual Suggestion:</a:t>
-            </a:r>
-          </a:p>
-          <a:p>
-            <a:r>
-              <a:t>Diagram of plant cell with chloroplasts</a:t>
             </a:r>
           </a:p>
         </p:txBody>
@@ -3375,13 +3239,6 @@
           <a:bodyPr/>
           <a:lstStyle/>
           <a:p>
-            <a:pPr>
-              <a:defRPr sz="3200" b="1">
-                <a:solidFill>
-                  <a:srgbClr val="1F497D"/>
-                </a:solidFill>
-              </a:defRPr>
-            </a:pPr>
             <a:r>
               <a:t>The Photosynthesis Equation</a:t>
             </a:r>
@@ -3403,69 +3260,15 @@
           <a:bodyPr/>
           <a:lstStyle/>
           <a:p>
-            <a:pPr>
-              <a:defRPr sz="2000">
-                <a:solidFill>
-                  <a:srgbClr val="444444"/>
-                </a:solidFill>
-              </a:defRPr>
-            </a:pPr>
+            <a:pPr/>
             <a:r>
               <a:t>6CO2 + 6H2O + light energy → C6H12O6 + 6O2</a:t>
             </a:r>
           </a:p>
           <a:p>
-            <a:pPr>
-              <a:defRPr sz="2000">
-                <a:solidFill>
-                  <a:srgbClr val="444444"/>
-                </a:solidFill>
-              </a:defRPr>
-            </a:pPr>
+            <a:pPr/>
             <a:r>
               <a:t>Carbon dioxide + Water + Light → Glucose + Oxygen</a:t>
-            </a:r>
-          </a:p>
-        </p:txBody>
-      </p:sp>
-      <p:sp>
-        <p:nvSpPr>
-          <p:cNvPr id="4" name="TextBox 3"/>
-          <p:cNvSpPr txBox="1"/>
-          <p:nvPr/>
-        </p:nvSpPr>
-        <p:spPr>
-          <a:xfrm>
-            <a:off x="7315200" y="5029200"/>
-            <a:ext cx="4114800" cy="1371600"/>
-          </a:xfrm>
-          <a:prstGeom prst="rect">
-            <a:avLst/>
-          </a:prstGeom>
-          <a:solidFill>
-            <a:srgbClr val="F0F0F0"/>
-          </a:solidFill>
-        </p:spPr>
-        <p:txBody>
-          <a:bodyPr wrap="none">
-            <a:spAutoFit/>
-          </a:bodyPr>
-          <a:lstStyle/>
-          <a:p>
-            <a:pPr>
-              <a:defRPr sz="1200" i="1">
-                <a:solidFill>
-                  <a:srgbClr val="808080"/>
-                </a:solidFill>
-              </a:defRPr>
-            </a:pPr>
-            <a:r>
-              <a:t>💡 Visual Suggestion:</a:t>
-            </a:r>
-          </a:p>
-          <a:p>
-            <a:r>
-              <a:t>Chemical equation diagram</a:t>
             </a:r>
           </a:p>
         </p:txBody>
@@ -3503,13 +3306,6 @@
           <a:bodyPr/>
           <a:lstStyle/>
           <a:p>
-            <a:pPr>
-              <a:defRPr sz="3600" b="1">
-                <a:solidFill>
-                  <a:srgbClr val="C00000"/>
-                </a:solidFill>
-              </a:defRPr>
-            </a:pPr>
             <a:r>
               <a:t>Key Takeaways</a:t>
             </a:r>
@@ -3531,37 +3327,19 @@
           <a:bodyPr/>
           <a:lstStyle/>
           <a:p>
-            <a:pPr>
-              <a:defRPr sz="2200" b="1">
-                <a:solidFill>
-                  <a:srgbClr val="1F497D"/>
-                </a:solidFill>
-              </a:defRPr>
-            </a:pPr>
+            <a:pPr/>
             <a:r>
               <a:t>Photosynthesis is vital for life on Earth</a:t>
             </a:r>
           </a:p>
           <a:p>
-            <a:pPr>
-              <a:defRPr sz="2200" b="1">
-                <a:solidFill>
-                  <a:srgbClr val="1F497D"/>
-                </a:solidFill>
-              </a:defRPr>
-            </a:pPr>
+            <a:pPr/>
             <a:r>
               <a:t>It produces oxygen and organic compounds</a:t>
             </a:r>
           </a:p>
           <a:p>
-            <a:pPr>
-              <a:defRPr sz="2200" b="1">
-                <a:solidFill>
-                  <a:srgbClr val="1F497D"/>
-                </a:solidFill>
-              </a:defRPr>
-            </a:pPr>
+            <a:pPr/>
             <a:r>
               <a:t>Understanding this process helps us appreciate nature</a:t>
             </a:r>

</xml_diff>